<commit_message>
Site updated: YYYY-10-2026年10月22日 18:56:53
</commit_message>
<xml_diff>
--- a/ppt/report.pptx
+++ b/ppt/report.pptx
@@ -1,6 +1,6 @@
 
 <file path=ppt/presentation.xml><?xml version="1.0" encoding="utf-8"?>
-<p:presentation xmlns:a="http://schemas.openxmlformats.org/drawingml/2006/main" xmlns:r="http://schemas.openxmlformats.org/officeDocument/2006/relationships" xmlns:p="http://schemas.openxmlformats.org/presentationml/2006/main" saveSubsetFonts="1">
+<p:presentation xmlns:a="http://schemas.openxmlformats.org/drawingml/2006/main" xmlns:r="http://schemas.openxmlformats.org/officeDocument/2006/relationships" xmlns:p="http://schemas.openxmlformats.org/presentationml/2006/main" embedTrueTypeFonts="1" saveSubsetFonts="1">
   <p:sldMasterIdLst>
     <p:sldMasterId id="2147483648" r:id="rId1"/>
   </p:sldMasterIdLst>
@@ -28,6 +28,17 @@
   </p:sldIdLst>
   <p:sldSz cx="12192000" cy="6858000"/>
   <p:notesSz cx="6858000" cy="9144000"/>
+  <p:embeddedFontLst>
+    <p:embeddedFont>
+      <p:font typeface="等线" panose="02010600030101010101" pitchFamily="2" charset="-122"/>
+      <p:regular r:id="rId20"/>
+      <p:bold r:id="rId21"/>
+    </p:embeddedFont>
+    <p:embeddedFont>
+      <p:font typeface="等线 Light" panose="02010600030101010101" pitchFamily="2" charset="-122"/>
+      <p:regular r:id="rId22"/>
+    </p:embeddedFont>
+  </p:embeddedFontLst>
   <p:defaultTextStyle>
     <a:defPPr>
       <a:defRPr lang="zh-CN"/>
@@ -123,6 +134,11 @@
       </a:defRPr>
     </a:lvl9pPr>
   </p:defaultTextStyle>
+  <p:extLst>
+    <p:ext uri="{EFAFB233-063F-42B5-8137-9DF3F51BA10A}">
+      <p15:sldGuideLst xmlns:p15="http://schemas.microsoft.com/office/powerpoint/2012/main"/>
+    </p:ext>
+  </p:extLst>
 </p:presentation>
 </file>
 
@@ -208,7 +224,7 @@
           <a:p>
             <a:fld id="{2CCF25C1-0400-491B-BFC7-99D8AE49ED5F}" type="datetimeFigureOut">
               <a:rPr lang="zh-CN" altLang="en-US" smtClean="0"/>
-              <a:t>2026/10/19</a:t>
+              <a:t>2026/10/22</a:t>
             </a:fld>
             <a:endParaRPr lang="zh-CN" altLang="en-US"/>
           </a:p>
@@ -706,7 +722,7 @@
           <a:p>
             <a:fld id="{49CC52F1-251D-4BC4-8249-C2095CF76BB3}" type="datetimeFigureOut">
               <a:rPr lang="zh-CN" altLang="en-US" smtClean="0"/>
-              <a:t>2026/10/19</a:t>
+              <a:t>2026/10/22</a:t>
             </a:fld>
             <a:endParaRPr lang="zh-CN" altLang="en-US"/>
           </a:p>
@@ -904,7 +920,7 @@
           <a:p>
             <a:fld id="{49CC52F1-251D-4BC4-8249-C2095CF76BB3}" type="datetimeFigureOut">
               <a:rPr lang="zh-CN" altLang="en-US" smtClean="0"/>
-              <a:t>2026/10/19</a:t>
+              <a:t>2026/10/22</a:t>
             </a:fld>
             <a:endParaRPr lang="zh-CN" altLang="en-US"/>
           </a:p>
@@ -1112,7 +1128,7 @@
           <a:p>
             <a:fld id="{49CC52F1-251D-4BC4-8249-C2095CF76BB3}" type="datetimeFigureOut">
               <a:rPr lang="zh-CN" altLang="en-US" smtClean="0"/>
-              <a:t>2026/10/19</a:t>
+              <a:t>2026/10/22</a:t>
             </a:fld>
             <a:endParaRPr lang="zh-CN" altLang="en-US"/>
           </a:p>
@@ -1310,7 +1326,7 @@
           <a:p>
             <a:fld id="{49CC52F1-251D-4BC4-8249-C2095CF76BB3}" type="datetimeFigureOut">
               <a:rPr lang="zh-CN" altLang="en-US" smtClean="0"/>
-              <a:t>2026/10/19</a:t>
+              <a:t>2026/10/22</a:t>
             </a:fld>
             <a:endParaRPr lang="zh-CN" altLang="en-US"/>
           </a:p>
@@ -1585,7 +1601,7 @@
           <a:p>
             <a:fld id="{49CC52F1-251D-4BC4-8249-C2095CF76BB3}" type="datetimeFigureOut">
               <a:rPr lang="zh-CN" altLang="en-US" smtClean="0"/>
-              <a:t>2026/10/19</a:t>
+              <a:t>2026/10/22</a:t>
             </a:fld>
             <a:endParaRPr lang="zh-CN" altLang="en-US"/>
           </a:p>
@@ -1850,7 +1866,7 @@
           <a:p>
             <a:fld id="{49CC52F1-251D-4BC4-8249-C2095CF76BB3}" type="datetimeFigureOut">
               <a:rPr lang="zh-CN" altLang="en-US" smtClean="0"/>
-              <a:t>2026/10/19</a:t>
+              <a:t>2026/10/22</a:t>
             </a:fld>
             <a:endParaRPr lang="zh-CN" altLang="en-US"/>
           </a:p>
@@ -2262,7 +2278,7 @@
           <a:p>
             <a:fld id="{49CC52F1-251D-4BC4-8249-C2095CF76BB3}" type="datetimeFigureOut">
               <a:rPr lang="zh-CN" altLang="en-US" smtClean="0"/>
-              <a:t>2026/10/19</a:t>
+              <a:t>2026/10/22</a:t>
             </a:fld>
             <a:endParaRPr lang="zh-CN" altLang="en-US"/>
           </a:p>
@@ -2403,7 +2419,7 @@
           <a:p>
             <a:fld id="{49CC52F1-251D-4BC4-8249-C2095CF76BB3}" type="datetimeFigureOut">
               <a:rPr lang="zh-CN" altLang="en-US" smtClean="0"/>
-              <a:t>2026/10/19</a:t>
+              <a:t>2026/10/22</a:t>
             </a:fld>
             <a:endParaRPr lang="zh-CN" altLang="en-US"/>
           </a:p>
@@ -2516,7 +2532,7 @@
           <a:p>
             <a:fld id="{49CC52F1-251D-4BC4-8249-C2095CF76BB3}" type="datetimeFigureOut">
               <a:rPr lang="zh-CN" altLang="en-US" smtClean="0"/>
-              <a:t>2026/10/19</a:t>
+              <a:t>2026/10/22</a:t>
             </a:fld>
             <a:endParaRPr lang="zh-CN" altLang="en-US"/>
           </a:p>
@@ -2827,7 +2843,7 @@
           <a:p>
             <a:fld id="{49CC52F1-251D-4BC4-8249-C2095CF76BB3}" type="datetimeFigureOut">
               <a:rPr lang="zh-CN" altLang="en-US" smtClean="0"/>
-              <a:t>2026/10/19</a:t>
+              <a:t>2026/10/22</a:t>
             </a:fld>
             <a:endParaRPr lang="zh-CN" altLang="en-US"/>
           </a:p>
@@ -3115,7 +3131,7 @@
           <a:p>
             <a:fld id="{49CC52F1-251D-4BC4-8249-C2095CF76BB3}" type="datetimeFigureOut">
               <a:rPr lang="zh-CN" altLang="en-US" smtClean="0"/>
-              <a:t>2026/10/19</a:t>
+              <a:t>2026/10/22</a:t>
             </a:fld>
             <a:endParaRPr lang="zh-CN" altLang="en-US"/>
           </a:p>
@@ -3356,7 +3372,7 @@
           <a:p>
             <a:fld id="{49CC52F1-251D-4BC4-8249-C2095CF76BB3}" type="datetimeFigureOut">
               <a:rPr lang="zh-CN" altLang="en-US" smtClean="0"/>
-              <a:t>2026/10/19</a:t>
+              <a:t>2026/10/22</a:t>
             </a:fld>
             <a:endParaRPr lang="zh-CN" altLang="en-US"/>
           </a:p>
@@ -3939,13 +3955,13 @@
   <p:clrMapOvr>
     <a:masterClrMapping/>
   </p:clrMapOvr>
-  <mc:AlternateContent xmlns:mc="http://schemas.openxmlformats.org/markup-compatibility/2006">
-    <mc:Choice xmlns:p159="http://schemas.microsoft.com/office/powerpoint/2015/09/main" Requires="p159">
+  <mc:AlternateContent xmlns:mc="http://schemas.openxmlformats.org/markup-compatibility/2006" xmlns:p159="http://schemas.microsoft.com/office/powerpoint/2015/09/main">
+    <mc:Choice Requires="p159">
       <p:transition spd="slow">
         <p159:morph option="byObject"/>
       </p:transition>
     </mc:Choice>
-    <mc:Fallback>
+    <mc:Fallback xmlns="">
       <p:transition spd="slow">
         <p:fade/>
       </p:transition>
@@ -4026,13 +4042,13 @@
   <p:clrMapOvr>
     <a:masterClrMapping/>
   </p:clrMapOvr>
-  <mc:AlternateContent xmlns:mc="http://schemas.openxmlformats.org/markup-compatibility/2006">
-    <mc:Choice xmlns:p14="http://schemas.microsoft.com/office/powerpoint/2010/main" Requires="p14">
+  <mc:AlternateContent xmlns:mc="http://schemas.openxmlformats.org/markup-compatibility/2006" xmlns:p14="http://schemas.microsoft.com/office/powerpoint/2010/main">
+    <mc:Choice Requires="p14">
       <p:transition spd="med" p14:dur="700">
         <p:fade/>
       </p:transition>
     </mc:Choice>
-    <mc:Fallback>
+    <mc:Fallback xmlns="">
       <p:transition spd="med">
         <p:fade/>
       </p:transition>
@@ -4152,13 +4168,13 @@
   <p:clrMapOvr>
     <a:masterClrMapping/>
   </p:clrMapOvr>
-  <mc:AlternateContent xmlns:mc="http://schemas.openxmlformats.org/markup-compatibility/2006">
-    <mc:Choice xmlns:p159="http://schemas.microsoft.com/office/powerpoint/2015/09/main" Requires="p159">
+  <mc:AlternateContent xmlns:mc="http://schemas.openxmlformats.org/markup-compatibility/2006" xmlns:p159="http://schemas.microsoft.com/office/powerpoint/2015/09/main">
+    <mc:Choice Requires="p159">
       <p:transition spd="slow">
         <p159:morph option="byObject"/>
       </p:transition>
     </mc:Choice>
-    <mc:Fallback>
+    <mc:Fallback xmlns="">
       <p:transition spd="slow">
         <p:fade/>
       </p:transition>
@@ -4395,13 +4411,13 @@
   <p:clrMapOvr>
     <a:masterClrMapping/>
   </p:clrMapOvr>
-  <mc:AlternateContent xmlns:mc="http://schemas.openxmlformats.org/markup-compatibility/2006">
-    <mc:Choice xmlns:p159="http://schemas.microsoft.com/office/powerpoint/2015/09/main" Requires="p159">
+  <mc:AlternateContent xmlns:mc="http://schemas.openxmlformats.org/markup-compatibility/2006" xmlns:p159="http://schemas.microsoft.com/office/powerpoint/2015/09/main">
+    <mc:Choice Requires="p159">
       <p:transition spd="slow">
         <p159:morph option="byObject"/>
       </p:transition>
     </mc:Choice>
-    <mc:Fallback>
+    <mc:Fallback xmlns="">
       <p:transition spd="slow">
         <p:fade/>
       </p:transition>
@@ -4521,13 +4537,13 @@
   <p:clrMapOvr>
     <a:masterClrMapping/>
   </p:clrMapOvr>
-  <mc:AlternateContent xmlns:mc="http://schemas.openxmlformats.org/markup-compatibility/2006">
-    <mc:Choice xmlns:p159="http://schemas.microsoft.com/office/powerpoint/2015/09/main" Requires="p159">
+  <mc:AlternateContent xmlns:mc="http://schemas.openxmlformats.org/markup-compatibility/2006" xmlns:p159="http://schemas.microsoft.com/office/powerpoint/2015/09/main">
+    <mc:Choice Requires="p159">
       <p:transition spd="slow">
         <p159:morph option="byObject"/>
       </p:transition>
     </mc:Choice>
-    <mc:Fallback>
+    <mc:Fallback xmlns="">
       <p:transition spd="slow">
         <p:fade/>
       </p:transition>
@@ -4647,13 +4663,13 @@
   <p:clrMapOvr>
     <a:masterClrMapping/>
   </p:clrMapOvr>
-  <mc:AlternateContent xmlns:mc="http://schemas.openxmlformats.org/markup-compatibility/2006">
-    <mc:Choice xmlns:p159="http://schemas.microsoft.com/office/powerpoint/2015/09/main" Requires="p159">
+  <mc:AlternateContent xmlns:mc="http://schemas.openxmlformats.org/markup-compatibility/2006" xmlns:p159="http://schemas.microsoft.com/office/powerpoint/2015/09/main">
+    <mc:Choice Requires="p159">
       <p:transition spd="slow">
         <p159:morph option="byObject"/>
       </p:transition>
     </mc:Choice>
-    <mc:Fallback>
+    <mc:Fallback xmlns="">
       <p:transition spd="slow">
         <p:fade/>
       </p:transition>
@@ -4957,13 +4973,13 @@
   <p:clrMapOvr>
     <a:masterClrMapping/>
   </p:clrMapOvr>
-  <mc:AlternateContent xmlns:mc="http://schemas.openxmlformats.org/markup-compatibility/2006">
-    <mc:Choice xmlns:p159="http://schemas.microsoft.com/office/powerpoint/2015/09/main" Requires="p159">
+  <mc:AlternateContent xmlns:mc="http://schemas.openxmlformats.org/markup-compatibility/2006" xmlns:p159="http://schemas.microsoft.com/office/powerpoint/2015/09/main">
+    <mc:Choice Requires="p159">
       <p:transition spd="slow">
         <p159:morph option="byObject"/>
       </p:transition>
     </mc:Choice>
-    <mc:Fallback>
+    <mc:Fallback xmlns="">
       <p:transition spd="slow">
         <p:fade/>
       </p:transition>
@@ -5038,13 +5054,13 @@
   <p:clrMapOvr>
     <a:masterClrMapping/>
   </p:clrMapOvr>
-  <mc:AlternateContent xmlns:mc="http://schemas.openxmlformats.org/markup-compatibility/2006">
-    <mc:Choice xmlns:p14="http://schemas.microsoft.com/office/powerpoint/2010/main" Requires="p14">
+  <mc:AlternateContent xmlns:mc="http://schemas.openxmlformats.org/markup-compatibility/2006" xmlns:p14="http://schemas.microsoft.com/office/powerpoint/2010/main">
+    <mc:Choice Requires="p14">
       <p:transition spd="med" p14:dur="700">
         <p:fade/>
       </p:transition>
     </mc:Choice>
-    <mc:Fallback>
+    <mc:Fallback xmlns="">
       <p:transition spd="med">
         <p:fade/>
       </p:transition>
@@ -5334,13 +5350,13 @@
   <p:clrMapOvr>
     <a:masterClrMapping/>
   </p:clrMapOvr>
-  <mc:AlternateContent xmlns:mc="http://schemas.openxmlformats.org/markup-compatibility/2006">
-    <mc:Choice xmlns:p14="http://schemas.microsoft.com/office/powerpoint/2010/main" Requires="p14">
+  <mc:AlternateContent xmlns:mc="http://schemas.openxmlformats.org/markup-compatibility/2006" xmlns:p14="http://schemas.microsoft.com/office/powerpoint/2010/main">
+    <mc:Choice Requires="p14">
       <p:transition spd="med" p14:dur="700">
         <p:fade/>
       </p:transition>
     </mc:Choice>
-    <mc:Fallback>
+    <mc:Fallback xmlns="">
       <p:transition spd="med">
         <p:fade/>
       </p:transition>
@@ -5579,13 +5595,13 @@
   <p:clrMapOvr>
     <a:masterClrMapping/>
   </p:clrMapOvr>
-  <mc:AlternateContent xmlns:mc="http://schemas.openxmlformats.org/markup-compatibility/2006">
-    <mc:Choice xmlns:p14="http://schemas.microsoft.com/office/powerpoint/2010/main" Requires="p14">
+  <mc:AlternateContent xmlns:mc="http://schemas.openxmlformats.org/markup-compatibility/2006" xmlns:p14="http://schemas.microsoft.com/office/powerpoint/2010/main">
+    <mc:Choice Requires="p14">
       <p:transition spd="med" p14:dur="700">
         <p:fade/>
       </p:transition>
     </mc:Choice>
-    <mc:Fallback>
+    <mc:Fallback xmlns="">
       <p:transition spd="med">
         <p:fade/>
       </p:transition>
@@ -5933,13 +5949,13 @@
   <p:clrMapOvr>
     <a:masterClrMapping/>
   </p:clrMapOvr>
-  <mc:AlternateContent xmlns:mc="http://schemas.openxmlformats.org/markup-compatibility/2006">
-    <mc:Choice xmlns:p159="http://schemas.microsoft.com/office/powerpoint/2015/09/main" Requires="p159">
+  <mc:AlternateContent xmlns:mc="http://schemas.openxmlformats.org/markup-compatibility/2006" xmlns:p159="http://schemas.microsoft.com/office/powerpoint/2015/09/main">
+    <mc:Choice Requires="p159">
       <p:transition spd="slow">
         <p159:morph option="byObject"/>
       </p:transition>
     </mc:Choice>
-    <mc:Fallback>
+    <mc:Fallback xmlns="">
       <p:transition spd="slow">
         <p:fade/>
       </p:transition>
@@ -6413,13 +6429,13 @@
   <p:clrMapOvr>
     <a:masterClrMapping/>
   </p:clrMapOvr>
-  <mc:AlternateContent xmlns:mc="http://schemas.openxmlformats.org/markup-compatibility/2006">
-    <mc:Choice xmlns:p159="http://schemas.microsoft.com/office/powerpoint/2015/09/main" Requires="p159">
+  <mc:AlternateContent xmlns:mc="http://schemas.openxmlformats.org/markup-compatibility/2006" xmlns:p159="http://schemas.microsoft.com/office/powerpoint/2015/09/main">
+    <mc:Choice Requires="p159">
       <p:transition spd="slow">
         <p159:morph option="byObject"/>
       </p:transition>
     </mc:Choice>
-    <mc:Fallback>
+    <mc:Fallback xmlns="">
       <p:transition spd="slow">
         <p:fade/>
       </p:transition>
@@ -6533,13 +6549,13 @@
   <p:clrMapOvr>
     <a:masterClrMapping/>
   </p:clrMapOvr>
-  <mc:AlternateContent xmlns:mc="http://schemas.openxmlformats.org/markup-compatibility/2006">
-    <mc:Choice xmlns:p14="http://schemas.microsoft.com/office/powerpoint/2010/main" Requires="p14">
+  <mc:AlternateContent xmlns:mc="http://schemas.openxmlformats.org/markup-compatibility/2006" xmlns:p14="http://schemas.microsoft.com/office/powerpoint/2010/main">
+    <mc:Choice Requires="p14">
       <p:transition spd="med" p14:dur="700">
         <p:fade/>
       </p:transition>
     </mc:Choice>
-    <mc:Fallback>
+    <mc:Fallback xmlns="">
       <p:transition spd="med">
         <p:fade/>
       </p:transition>
@@ -6731,13 +6747,13 @@
   <p:clrMapOvr>
     <a:masterClrMapping/>
   </p:clrMapOvr>
-  <mc:AlternateContent xmlns:mc="http://schemas.openxmlformats.org/markup-compatibility/2006">
-    <mc:Choice xmlns:p159="http://schemas.microsoft.com/office/powerpoint/2015/09/main" Requires="p159">
+  <mc:AlternateContent xmlns:mc="http://schemas.openxmlformats.org/markup-compatibility/2006" xmlns:p159="http://schemas.microsoft.com/office/powerpoint/2015/09/main">
+    <mc:Choice Requires="p159">
       <p:transition xmlns:p14="http://schemas.microsoft.com/office/powerpoint/2010/main" spd="slow" p14:dur="2000">
         <p159:morph option="byObject"/>
       </p:transition>
     </mc:Choice>
-    <mc:Fallback>
+    <mc:Fallback xmlns="">
       <p:transition spd="slow">
         <p:fade/>
       </p:transition>
@@ -6974,13 +6990,13 @@
   <p:clrMapOvr>
     <a:masterClrMapping/>
   </p:clrMapOvr>
-  <mc:AlternateContent xmlns:mc="http://schemas.openxmlformats.org/markup-compatibility/2006">
-    <mc:Choice xmlns:p159="http://schemas.microsoft.com/office/powerpoint/2015/09/main" Requires="p159">
+  <mc:AlternateContent xmlns:mc="http://schemas.openxmlformats.org/markup-compatibility/2006" xmlns:p159="http://schemas.microsoft.com/office/powerpoint/2015/09/main">
+    <mc:Choice Requires="p159">
       <p:transition spd="slow">
         <p159:morph option="byObject"/>
       </p:transition>
     </mc:Choice>
-    <mc:Fallback>
+    <mc:Fallback xmlns="">
       <p:transition spd="slow">
         <p:fade/>
       </p:transition>
@@ -7100,13 +7116,13 @@
   <p:clrMapOvr>
     <a:masterClrMapping/>
   </p:clrMapOvr>
-  <mc:AlternateContent xmlns:mc="http://schemas.openxmlformats.org/markup-compatibility/2006">
-    <mc:Choice xmlns:p159="http://schemas.microsoft.com/office/powerpoint/2015/09/main" Requires="p159">
+  <mc:AlternateContent xmlns:mc="http://schemas.openxmlformats.org/markup-compatibility/2006" xmlns:p159="http://schemas.microsoft.com/office/powerpoint/2015/09/main">
+    <mc:Choice Requires="p159">
       <p:transition spd="slow">
         <p159:morph option="byObject"/>
       </p:transition>
     </mc:Choice>
-    <mc:Fallback>
+    <mc:Fallback xmlns="">
       <p:transition spd="slow">
         <p:fade/>
       </p:transition>

</xml_diff>